<commit_message>
[ANV] updated Marion pictures
</commit_message>
<xml_diff>
--- a/Marion_2-22.pptx
+++ b/Marion_2-22.pptx
@@ -6,6 +6,9 @@
   </p:sldMasterIdLst>
   <p:sldIdLst>
     <p:sldId id="256" r:id="rId2"/>
+    <p:sldId id="257" r:id="rId3"/>
+    <p:sldId id="258" r:id="rId4"/>
+    <p:sldId id="259" r:id="rId5"/>
   </p:sldIdLst>
   <p:sldSz cx="12192000" cy="6858000"/>
   <p:notesSz cx="6858000" cy="9144000"/>
@@ -104,6 +107,11 @@
       </a:defRPr>
     </a:lvl9pPr>
   </p:defaultTextStyle>
+  <p:extLst>
+    <p:ext uri="{EFAFB233-063F-42B5-8137-9DF3F51BA10A}">
+      <p15:sldGuideLst xmlns:p15="http://schemas.microsoft.com/office/powerpoint/2012/main"/>
+    </p:ext>
+  </p:extLst>
 </p:presentation>
 </file>
 
@@ -254,7 +262,7 @@
           <a:p>
             <a:fld id="{219D0A22-8AA9-F24B-8D1F-6D6F4F6E72BF}" type="datetimeFigureOut">
               <a:rPr lang="en-US" smtClean="0"/>
-              <a:t>9/24/25</a:t>
+              <a:t>10/3/25</a:t>
             </a:fld>
             <a:endParaRPr lang="en-US"/>
           </a:p>
@@ -452,7 +460,7 @@
           <a:p>
             <a:fld id="{219D0A22-8AA9-F24B-8D1F-6D6F4F6E72BF}" type="datetimeFigureOut">
               <a:rPr lang="en-US" smtClean="0"/>
-              <a:t>9/24/25</a:t>
+              <a:t>10/3/25</a:t>
             </a:fld>
             <a:endParaRPr lang="en-US"/>
           </a:p>
@@ -660,7 +668,7 @@
           <a:p>
             <a:fld id="{219D0A22-8AA9-F24B-8D1F-6D6F4F6E72BF}" type="datetimeFigureOut">
               <a:rPr lang="en-US" smtClean="0"/>
-              <a:t>9/24/25</a:t>
+              <a:t>10/3/25</a:t>
             </a:fld>
             <a:endParaRPr lang="en-US"/>
           </a:p>
@@ -858,7 +866,7 @@
           <a:p>
             <a:fld id="{219D0A22-8AA9-F24B-8D1F-6D6F4F6E72BF}" type="datetimeFigureOut">
               <a:rPr lang="en-US" smtClean="0"/>
-              <a:t>9/24/25</a:t>
+              <a:t>10/3/25</a:t>
             </a:fld>
             <a:endParaRPr lang="en-US"/>
           </a:p>
@@ -1133,7 +1141,7 @@
           <a:p>
             <a:fld id="{219D0A22-8AA9-F24B-8D1F-6D6F4F6E72BF}" type="datetimeFigureOut">
               <a:rPr lang="en-US" smtClean="0"/>
-              <a:t>9/24/25</a:t>
+              <a:t>10/3/25</a:t>
             </a:fld>
             <a:endParaRPr lang="en-US"/>
           </a:p>
@@ -1398,7 +1406,7 @@
           <a:p>
             <a:fld id="{219D0A22-8AA9-F24B-8D1F-6D6F4F6E72BF}" type="datetimeFigureOut">
               <a:rPr lang="en-US" smtClean="0"/>
-              <a:t>9/24/25</a:t>
+              <a:t>10/3/25</a:t>
             </a:fld>
             <a:endParaRPr lang="en-US"/>
           </a:p>
@@ -1810,7 +1818,7 @@
           <a:p>
             <a:fld id="{219D0A22-8AA9-F24B-8D1F-6D6F4F6E72BF}" type="datetimeFigureOut">
               <a:rPr lang="en-US" smtClean="0"/>
-              <a:t>9/24/25</a:t>
+              <a:t>10/3/25</a:t>
             </a:fld>
             <a:endParaRPr lang="en-US"/>
           </a:p>
@@ -1951,7 +1959,7 @@
           <a:p>
             <a:fld id="{219D0A22-8AA9-F24B-8D1F-6D6F4F6E72BF}" type="datetimeFigureOut">
               <a:rPr lang="en-US" smtClean="0"/>
-              <a:t>9/24/25</a:t>
+              <a:t>10/3/25</a:t>
             </a:fld>
             <a:endParaRPr lang="en-US"/>
           </a:p>
@@ -2064,7 +2072,7 @@
           <a:p>
             <a:fld id="{219D0A22-8AA9-F24B-8D1F-6D6F4F6E72BF}" type="datetimeFigureOut">
               <a:rPr lang="en-US" smtClean="0"/>
-              <a:t>9/24/25</a:t>
+              <a:t>10/3/25</a:t>
             </a:fld>
             <a:endParaRPr lang="en-US"/>
           </a:p>
@@ -2375,7 +2383,7 @@
           <a:p>
             <a:fld id="{219D0A22-8AA9-F24B-8D1F-6D6F4F6E72BF}" type="datetimeFigureOut">
               <a:rPr lang="en-US" smtClean="0"/>
-              <a:t>9/24/25</a:t>
+              <a:t>10/3/25</a:t>
             </a:fld>
             <a:endParaRPr lang="en-US"/>
           </a:p>
@@ -2663,7 +2671,7 @@
           <a:p>
             <a:fld id="{219D0A22-8AA9-F24B-8D1F-6D6F4F6E72BF}" type="datetimeFigureOut">
               <a:rPr lang="en-US" smtClean="0"/>
-              <a:t>9/24/25</a:t>
+              <a:t>10/3/25</a:t>
             </a:fld>
             <a:endParaRPr lang="en-US"/>
           </a:p>
@@ -2904,7 +2912,7 @@
           <a:p>
             <a:fld id="{219D0A22-8AA9-F24B-8D1F-6D6F4F6E72BF}" type="datetimeFigureOut">
               <a:rPr lang="en-US" smtClean="0"/>
-              <a:t>9/24/25</a:t>
+              <a:t>10/3/25</a:t>
             </a:fld>
             <a:endParaRPr lang="en-US"/>
           </a:p>
@@ -3364,6 +3372,372 @@
 </p:sld>
 </file>
 
+<file path=ppt/slides/slide2.xml><?xml version="1.0" encoding="utf-8"?>
+<p:sld xmlns:a="http://schemas.openxmlformats.org/drawingml/2006/main" xmlns:r="http://schemas.openxmlformats.org/officeDocument/2006/relationships" xmlns:p="http://schemas.openxmlformats.org/presentationml/2006/main">
+  <p:cSld>
+    <p:spTree>
+      <p:nvGrpSpPr>
+        <p:cNvPr id="1" name="">
+          <a:extLst>
+            <a:ext uri="{FF2B5EF4-FFF2-40B4-BE49-F238E27FC236}">
+              <a16:creationId xmlns:a16="http://schemas.microsoft.com/office/drawing/2014/main" id="{27B7AE9D-9740-1A34-8675-AC0BBFB5889B}"/>
+            </a:ext>
+          </a:extLst>
+        </p:cNvPr>
+        <p:cNvGrpSpPr/>
+        <p:nvPr/>
+      </p:nvGrpSpPr>
+      <p:grpSpPr>
+        <a:xfrm>
+          <a:off x="0" y="0"/>
+          <a:ext cx="0" cy="0"/>
+          <a:chOff x="0" y="0"/>
+          <a:chExt cx="0" cy="0"/>
+        </a:xfrm>
+      </p:grpSpPr>
+      <p:grpSp>
+        <p:nvGrpSpPr>
+          <p:cNvPr id="4" name="Group 3">
+            <a:extLst>
+              <a:ext uri="{FF2B5EF4-FFF2-40B4-BE49-F238E27FC236}">
+                <a16:creationId xmlns:a16="http://schemas.microsoft.com/office/drawing/2014/main" id="{1C509C28-6E56-2931-944E-30BDDA34AEFB}"/>
+              </a:ext>
+            </a:extLst>
+          </p:cNvPr>
+          <p:cNvGrpSpPr/>
+          <p:nvPr/>
+        </p:nvGrpSpPr>
+        <p:grpSpPr>
+          <a:xfrm>
+            <a:off x="3473299" y="1501885"/>
+            <a:ext cx="5245401" cy="3854229"/>
+            <a:chOff x="3473299" y="1501885"/>
+            <a:chExt cx="5245401" cy="3854229"/>
+          </a:xfrm>
+        </p:grpSpPr>
+        <p:pic>
+          <p:nvPicPr>
+            <p:cNvPr id="2" name="Picture 1">
+              <a:extLst>
+                <a:ext uri="{FF2B5EF4-FFF2-40B4-BE49-F238E27FC236}">
+                  <a16:creationId xmlns:a16="http://schemas.microsoft.com/office/drawing/2014/main" id="{FB0F5C94-C3F9-34CB-7E3D-5BDF30548531}"/>
+                </a:ext>
+              </a:extLst>
+            </p:cNvPr>
+            <p:cNvPicPr>
+              <a:picLocks noChangeAspect="1"/>
+            </p:cNvPicPr>
+            <p:nvPr/>
+          </p:nvPicPr>
+          <p:blipFill>
+            <a:blip r:embed="rId2"/>
+            <a:stretch>
+              <a:fillRect/>
+            </a:stretch>
+          </p:blipFill>
+          <p:spPr>
+            <a:xfrm>
+              <a:off x="3473299" y="1501885"/>
+              <a:ext cx="5245401" cy="3854229"/>
+            </a:xfrm>
+            <a:prstGeom prst="rect">
+              <a:avLst/>
+            </a:prstGeom>
+          </p:spPr>
+        </p:pic>
+        <p:sp>
+          <p:nvSpPr>
+            <p:cNvPr id="3" name="TextBox 2">
+              <a:extLst>
+                <a:ext uri="{FF2B5EF4-FFF2-40B4-BE49-F238E27FC236}">
+                  <a16:creationId xmlns:a16="http://schemas.microsoft.com/office/drawing/2014/main" id="{1E87653A-180E-4D05-4B60-7521443DBA80}"/>
+                </a:ext>
+              </a:extLst>
+            </p:cNvPr>
+            <p:cNvSpPr txBox="1"/>
+            <p:nvPr/>
+          </p:nvSpPr>
+          <p:spPr>
+            <a:xfrm>
+              <a:off x="5107652" y="1843315"/>
+              <a:ext cx="1113382" cy="369332"/>
+            </a:xfrm>
+            <a:prstGeom prst="rect">
+              <a:avLst/>
+            </a:prstGeom>
+            <a:noFill/>
+          </p:spPr>
+          <p:txBody>
+            <a:bodyPr wrap="none" rtlCol="0">
+              <a:spAutoFit/>
+            </a:bodyPr>
+            <a:lstStyle/>
+            <a:p>
+              <a:r>
+                <a:rPr lang="en-US" dirty="0"/>
+                <a:t>A = |Ey/B|</a:t>
+              </a:r>
+            </a:p>
+          </p:txBody>
+        </p:sp>
+      </p:grpSp>
+    </p:spTree>
+    <p:extLst>
+      <p:ext uri="{BB962C8B-B14F-4D97-AF65-F5344CB8AC3E}">
+        <p14:creationId xmlns:p14="http://schemas.microsoft.com/office/powerpoint/2010/main" val="1595579489"/>
+      </p:ext>
+    </p:extLst>
+  </p:cSld>
+  <p:clrMapOvr>
+    <a:masterClrMapping/>
+  </p:clrMapOvr>
+</p:sld>
+</file>
+
+<file path=ppt/slides/slide3.xml><?xml version="1.0" encoding="utf-8"?>
+<p:sld xmlns:a="http://schemas.openxmlformats.org/drawingml/2006/main" xmlns:r="http://schemas.openxmlformats.org/officeDocument/2006/relationships" xmlns:p="http://schemas.openxmlformats.org/presentationml/2006/main">
+  <p:cSld>
+    <p:spTree>
+      <p:nvGrpSpPr>
+        <p:cNvPr id="1" name="">
+          <a:extLst>
+            <a:ext uri="{FF2B5EF4-FFF2-40B4-BE49-F238E27FC236}">
+              <a16:creationId xmlns:a16="http://schemas.microsoft.com/office/drawing/2014/main" id="{B884F79B-4A82-4FD9-A496-7E971A60B9CD}"/>
+            </a:ext>
+          </a:extLst>
+        </p:cNvPr>
+        <p:cNvGrpSpPr/>
+        <p:nvPr/>
+      </p:nvGrpSpPr>
+      <p:grpSpPr>
+        <a:xfrm>
+          <a:off x="0" y="0"/>
+          <a:ext cx="0" cy="0"/>
+          <a:chOff x="0" y="0"/>
+          <a:chExt cx="0" cy="0"/>
+        </a:xfrm>
+      </p:grpSpPr>
+      <p:grpSp>
+        <p:nvGrpSpPr>
+          <p:cNvPr id="6" name="Group 5">
+            <a:extLst>
+              <a:ext uri="{FF2B5EF4-FFF2-40B4-BE49-F238E27FC236}">
+                <a16:creationId xmlns:a16="http://schemas.microsoft.com/office/drawing/2014/main" id="{DCDD7DB7-550B-AFD2-621A-32B00A9847CA}"/>
+              </a:ext>
+            </a:extLst>
+          </p:cNvPr>
+          <p:cNvGrpSpPr/>
+          <p:nvPr/>
+        </p:nvGrpSpPr>
+        <p:grpSpPr>
+          <a:xfrm>
+            <a:off x="3497098" y="1501885"/>
+            <a:ext cx="5197802" cy="3854229"/>
+            <a:chOff x="3497098" y="1501885"/>
+            <a:chExt cx="5197802" cy="3854229"/>
+          </a:xfrm>
+        </p:grpSpPr>
+        <p:pic>
+          <p:nvPicPr>
+            <p:cNvPr id="5" name="Picture 4">
+              <a:extLst>
+                <a:ext uri="{FF2B5EF4-FFF2-40B4-BE49-F238E27FC236}">
+                  <a16:creationId xmlns:a16="http://schemas.microsoft.com/office/drawing/2014/main" id="{CEB4FD1B-802D-505E-0EBD-30ED17814022}"/>
+                </a:ext>
+              </a:extLst>
+            </p:cNvPr>
+            <p:cNvPicPr>
+              <a:picLocks noChangeAspect="1"/>
+            </p:cNvPicPr>
+            <p:nvPr/>
+          </p:nvPicPr>
+          <p:blipFill>
+            <a:blip r:embed="rId2"/>
+            <a:stretch>
+              <a:fillRect/>
+            </a:stretch>
+          </p:blipFill>
+          <p:spPr>
+            <a:xfrm>
+              <a:off x="3497098" y="1501885"/>
+              <a:ext cx="5197802" cy="3854229"/>
+            </a:xfrm>
+            <a:prstGeom prst="rect">
+              <a:avLst/>
+            </a:prstGeom>
+          </p:spPr>
+        </p:pic>
+        <p:sp>
+          <p:nvSpPr>
+            <p:cNvPr id="3" name="TextBox 2">
+              <a:extLst>
+                <a:ext uri="{FF2B5EF4-FFF2-40B4-BE49-F238E27FC236}">
+                  <a16:creationId xmlns:a16="http://schemas.microsoft.com/office/drawing/2014/main" id="{6F858C14-8AB4-2617-5C62-27A9C6A6AF3C}"/>
+                </a:ext>
+              </a:extLst>
+            </p:cNvPr>
+            <p:cNvSpPr txBox="1"/>
+            <p:nvPr/>
+          </p:nvSpPr>
+          <p:spPr>
+            <a:xfrm>
+              <a:off x="5107652" y="1843315"/>
+              <a:ext cx="1113382" cy="369332"/>
+            </a:xfrm>
+            <a:prstGeom prst="rect">
+              <a:avLst/>
+            </a:prstGeom>
+            <a:noFill/>
+          </p:spPr>
+          <p:txBody>
+            <a:bodyPr wrap="none" rtlCol="0">
+              <a:spAutoFit/>
+            </a:bodyPr>
+            <a:lstStyle/>
+            <a:p>
+              <a:r>
+                <a:rPr lang="en-US" dirty="0"/>
+                <a:t>A &lt; |Ey/B|</a:t>
+              </a:r>
+            </a:p>
+          </p:txBody>
+        </p:sp>
+      </p:grpSp>
+    </p:spTree>
+    <p:extLst>
+      <p:ext uri="{BB962C8B-B14F-4D97-AF65-F5344CB8AC3E}">
+        <p14:creationId xmlns:p14="http://schemas.microsoft.com/office/powerpoint/2010/main" val="343697617"/>
+      </p:ext>
+    </p:extLst>
+  </p:cSld>
+  <p:clrMapOvr>
+    <a:masterClrMapping/>
+  </p:clrMapOvr>
+</p:sld>
+</file>
+
+<file path=ppt/slides/slide4.xml><?xml version="1.0" encoding="utf-8"?>
+<p:sld xmlns:a="http://schemas.openxmlformats.org/drawingml/2006/main" xmlns:r="http://schemas.openxmlformats.org/officeDocument/2006/relationships" xmlns:p="http://schemas.openxmlformats.org/presentationml/2006/main">
+  <p:cSld>
+    <p:spTree>
+      <p:nvGrpSpPr>
+        <p:cNvPr id="1" name="">
+          <a:extLst>
+            <a:ext uri="{FF2B5EF4-FFF2-40B4-BE49-F238E27FC236}">
+              <a16:creationId xmlns:a16="http://schemas.microsoft.com/office/drawing/2014/main" id="{AA45EF19-96A9-6B3B-D144-5CA28356801C}"/>
+            </a:ext>
+          </a:extLst>
+        </p:cNvPr>
+        <p:cNvGrpSpPr/>
+        <p:nvPr/>
+      </p:nvGrpSpPr>
+      <p:grpSpPr>
+        <a:xfrm>
+          <a:off x="0" y="0"/>
+          <a:ext cx="0" cy="0"/>
+          <a:chOff x="0" y="0"/>
+          <a:chExt cx="0" cy="0"/>
+        </a:xfrm>
+      </p:grpSpPr>
+      <p:grpSp>
+        <p:nvGrpSpPr>
+          <p:cNvPr id="4" name="Group 3">
+            <a:extLst>
+              <a:ext uri="{FF2B5EF4-FFF2-40B4-BE49-F238E27FC236}">
+                <a16:creationId xmlns:a16="http://schemas.microsoft.com/office/drawing/2014/main" id="{5949FD89-B638-295E-B3E9-25550D83653C}"/>
+              </a:ext>
+            </a:extLst>
+          </p:cNvPr>
+          <p:cNvGrpSpPr/>
+          <p:nvPr/>
+        </p:nvGrpSpPr>
+        <p:grpSpPr>
+          <a:xfrm>
+            <a:off x="3497099" y="1489820"/>
+            <a:ext cx="5197802" cy="3878360"/>
+            <a:chOff x="3497099" y="1489820"/>
+            <a:chExt cx="5197802" cy="3878360"/>
+          </a:xfrm>
+        </p:grpSpPr>
+        <p:pic>
+          <p:nvPicPr>
+            <p:cNvPr id="2" name="Picture 1">
+              <a:extLst>
+                <a:ext uri="{FF2B5EF4-FFF2-40B4-BE49-F238E27FC236}">
+                  <a16:creationId xmlns:a16="http://schemas.microsoft.com/office/drawing/2014/main" id="{362EA84F-3C6E-06C4-1D55-2AD8009074A1}"/>
+                </a:ext>
+              </a:extLst>
+            </p:cNvPr>
+            <p:cNvPicPr>
+              <a:picLocks noChangeAspect="1"/>
+            </p:cNvPicPr>
+            <p:nvPr/>
+          </p:nvPicPr>
+          <p:blipFill>
+            <a:blip r:embed="rId2"/>
+            <a:stretch>
+              <a:fillRect/>
+            </a:stretch>
+          </p:blipFill>
+          <p:spPr>
+            <a:xfrm>
+              <a:off x="3497099" y="1489820"/>
+              <a:ext cx="5197802" cy="3878360"/>
+            </a:xfrm>
+            <a:prstGeom prst="rect">
+              <a:avLst/>
+            </a:prstGeom>
+          </p:spPr>
+        </p:pic>
+        <p:sp>
+          <p:nvSpPr>
+            <p:cNvPr id="3" name="TextBox 2">
+              <a:extLst>
+                <a:ext uri="{FF2B5EF4-FFF2-40B4-BE49-F238E27FC236}">
+                  <a16:creationId xmlns:a16="http://schemas.microsoft.com/office/drawing/2014/main" id="{ED905281-2A1D-79B5-F344-14E5EA243C17}"/>
+                </a:ext>
+              </a:extLst>
+            </p:cNvPr>
+            <p:cNvSpPr txBox="1"/>
+            <p:nvPr/>
+          </p:nvSpPr>
+          <p:spPr>
+            <a:xfrm>
+              <a:off x="4802853" y="1799772"/>
+              <a:ext cx="1113382" cy="369332"/>
+            </a:xfrm>
+            <a:prstGeom prst="rect">
+              <a:avLst/>
+            </a:prstGeom>
+            <a:noFill/>
+          </p:spPr>
+          <p:txBody>
+            <a:bodyPr wrap="none" rtlCol="0">
+              <a:spAutoFit/>
+            </a:bodyPr>
+            <a:lstStyle/>
+            <a:p>
+              <a:r>
+                <a:rPr lang="en-US" dirty="0"/>
+                <a:t>A &gt; |Ey/B|</a:t>
+              </a:r>
+            </a:p>
+          </p:txBody>
+        </p:sp>
+      </p:grpSp>
+    </p:spTree>
+    <p:extLst>
+      <p:ext uri="{BB962C8B-B14F-4D97-AF65-F5344CB8AC3E}">
+        <p14:creationId xmlns:p14="http://schemas.microsoft.com/office/powerpoint/2010/main" val="4052025475"/>
+      </p:ext>
+    </p:extLst>
+  </p:cSld>
+  <p:clrMapOvr>
+    <a:masterClrMapping/>
+  </p:clrMapOvr>
+</p:sld>
+</file>
+
 <file path=ppt/theme/theme1.xml><?xml version="1.0" encoding="utf-8"?>
 <a:theme xmlns:a="http://schemas.openxmlformats.org/drawingml/2006/main" name="Office Theme">
   <a:themeElements>

</xml_diff>